<commit_message>
Split speech between Egor and Sveta, compact text-only layout, add audience questions
Co-Authored-By: Claude Opus 5.5 <noreply@anthropic.com>
Claude-Session: https://claude.ai/code/session_019XwRdqvMoKnJvFiroXySfz
</commit_message>
<xml_diff>
--- a/cifrovizaciya/Цифровизация_общества_РФ.pptx
+++ b/cifrovizaciya/Цифровизация_общества_РФ.pptx
@@ -116,18 +116,18 @@
   <p:extLst>
     <p:ext uri="{521415D9-36F7-43E2-AB2F-B90AF26B5E84}">
       <p14:sectionLst xmlns:p14="http://schemas.microsoft.com/office/powerpoint/2010/main">
-        <p14:section name="Введение" id="{746e8307-c757-b770-fc7f-1088cbaf47ef}">
+        <p14:section name="Введение" id="{3b9367c3-3e10-c94f-80bb-82c06782f2ff}">
           <p14:sldIdLst>
             <p14:sldId id="256"/>
           </p14:sldIdLst>
         </p14:section>
-        <p14:section name="История" id="{2f84490f-1a0d-7550-f7d6-75f0ab48019c}">
+        <p14:section name="История" id="{9a2b20b6-0b26-ee88-ed53-112263fd3763}">
           <p14:sldIdLst>
             <p14:sldId id="257"/>
             <p14:sldId id="258"/>
           </p14:sldIdLst>
         </p14:section>
-        <p14:section name="Сферы жизни" id="{9b5837c6-df51-5be6-ba3b-f6dd3c9067f4}">
+        <p14:section name="Сферы жизни" id="{34a6ad39-b4c6-a979-fa85-a38cd7623641}">
           <p14:sldIdLst>
             <p14:sldId id="259"/>
             <p14:sldId id="260"/>
@@ -135,13 +135,13 @@
             <p14:sldId id="262"/>
           </p14:sldIdLst>
         </p14:section>
-        <p14:section name="Перелом и вызовы" id="{e0e9e4d6-5ce6-e23a-f5da-8160fe027602}">
+        <p14:section name="Перелом и вызовы" id="{46d08882-ffdd-65b6-c2fa-e9593adfd174}">
           <p14:sldIdLst>
             <p14:sldId id="263"/>
             <p14:sldId id="264"/>
           </p14:sldIdLst>
         </p14:section>
-        <p14:section name="Итоги" id="{01affb7b-c8a5-91ff-a90d-426e52805443}">
+        <p14:section name="Итоги" id="{83d88c01-f0ee-19fb-0d66-44ad287040b3}">
           <p14:sldIdLst>
             <p14:sldId id="265"/>
           </p14:sldIdLst>
@@ -550,8 +550,9 @@
           <a:p>
             <a:r>
               <a:rPr lang="en-US" dirty="0"/>
-              <a:t>Добрый день! Тема моего доклада — как цифровизация входила в жизнь общества России. Сразу оговорюсь: я не буду говорить об экономике, ВВП и рынке IT. Меня интересует другое — как цифровые технологии изменили повседневную жизнь обычного человека: как мы общаемся, учимся, лечимся, ездим по городу, ходим в театр и решаем вопросы с государством.
-Ещё тридцать лет назад интернет в России был диковинкой для учёных и энтузиастов. Сегодня у большинства из нас в кармане смартфон, через который можно записаться к врачу, проверить оценки ребёнка, оплатить проезд и купить билет в музей. Как мы к этому пришли — об этом и поговорим.</a:t>
+              <a:t>[Егор]
+Добрый день! Меня зовут Егор, а это Света. Тема нашего доклада — как цифровизация входила в жизнь общества России. Сразу оговоримся: мы не будем говорить об экономике, ВВП и рынке IT. Нас интересует другое — как цифровые технологии изменили повседневную жизнь обычного человека: как мы общаемся, учимся, лечимся, ездим по городу, ходим в театр и решаем вопросы с государством.
+Ещё тридцать лет назад интернет в России был диковинкой для учёных и энтузиастов. Сегодня у большинства из нас в кармане смартфон, через который можно записаться к врачу, проверить оценки ребёнка, оплатить проезд и купить билет в музей. Как мы к этому пришли — об этом и поговорим. Первую часть расскажу я, вторую — Света.</a:t>
             </a:r>
             <a:endParaRPr lang="en-US" dirty="0"/>
           </a:p>
@@ -639,9 +640,10 @@
           <a:p>
             <a:r>
               <a:rPr lang="en-US" dirty="0"/>
-              <a:t>Подведу итог. За тридцать с небольшим лет интернет в России прошёл путь от диковинки для энтузиастов до привычной среды — почти как электричество или водопровод. Мы замечаем его, только когда он пропадает.
+              <a:t>[Света]
+Подведу итог. За тридцать с небольшим лет интернет в России прошёл путь от диковинки для энтузиастов до привычной среды — почти как электричество или водопровод. Мы замечаем его, только когда он пропадает.
 Главные изменения оказались не экономическими, а человеческими: по-другому устроены учёба, лечение, общение с близкими и общение с государством.
-И, на мой взгляд, следующий шаг — не столько новые сервисы, сколько умение людей пользоваться ими безопасно и с пользой. Спасибо за внимание! Буду рад ответить на ваши вопросы.</a:t>
+И, на наш взгляд, следующий шаг — не столько новые сервисы, сколько умение людей пользоваться ими безопасно и с пользой. Спасибо за внимание! А теперь у нас есть несколько вопросов к залу.</a:t>
             </a:r>
             <a:endParaRPr lang="en-US" dirty="0"/>
           </a:p>
@@ -729,7 +731,8 @@
           <a:p>
             <a:r>
               <a:rPr lang="en-US" dirty="0"/>
-              <a:t>Отправной точкой российского интернета принято считать 7 апреля 1994 года — в этот день был зарегистрирован национальный домен .RU. У Рунета появился собственный «адрес», и эту дату до сих пор отмечают как день рождения Рунета.
+              <a:t>[Егор]
+Отправной точкой российского интернета принято считать 7 апреля 1994 года — в этот день был зарегистрирован национальный домен .RU. У Рунета появился собственный «адрес», и эту дату до сих пор отмечают как день рождения Рунета.
 Дальше события развивались быстро. В 1996 году заработал Rambler — один из первых российских поисковиков, в 1997 году появился Яндекс. Именно поисковики сделали интернет полезным для обычного человека: в сети стало можно найти расписание, новости, рецепт или ответ на вопрос.
 Следующий перелом — 2006 год, когда появились «ВКонтакте» и «Одноклассники». Общение начало уходить в сеть: люди находили одноклассников, сослуживцев, родственников в других городах. Интернет стал не только справочником, но и местом встречи.
 А в 2009 году открылся портал Госуслуг. Это важный символический момент: в интернет пришло государство. Об этом — чуть позже, а пока посмотрим, насколько широко сеть распространилась по стране.</a:t>
@@ -820,7 +823,8 @@
           <a:p>
             <a:r>
               <a:rPr lang="en-US" dirty="0"/>
-              <a:t>Главная цифра этого слайда — 90,4 процента. Столько домохозяйств в России было подключено к интернету в 2024 году, по оценке Института статистических исследований и экономики знаний ВШЭ на основе данных Росстата. За десять лет этот показатель вырос примерно на 20 процентных пунктов — с примерно 70 процентов в 2014 году.
+              <a:t>[Егор]
+Главная цифра этого слайда — 90,4 процента. Столько домохозяйств в России было подключено к интернету в 2024 году, по оценке Института статистических исследований и экономики знаний ВШЭ на основе данных Росстата. За десять лет этот показатель вырос примерно на 20 процентных пунктов — с примерно 70 процентов в 2014 году.
 Важно, как именно люди выходят в сеть. Для большинства главным «окном» в интернет стал не компьютер, а смартфон. Именно это сделало цифровые сервисы по-настоящему массовыми: теперь ими пользуются и школьники, и пенсионеры, у которых никогда не было ноутбука.
 Отдельная история — небольшие населённые пункты. По государственной программе устранения цифрового неравенства связь и интернет проводят в сёла и посёлки, куда коммерческим операторам заходить невыгодно. Так интернет постепенно перестаёт быть привилегией больших городов.</a:t>
             </a:r>
@@ -910,7 +914,8 @@
           <a:p>
             <a:r>
               <a:rPr lang="en-US" dirty="0"/>
-              <a:t>Если выбрать один символ цифровизации России, это, пожалуй, Госуслуги. Портал запустили 15 декабря 2009 года, а к концу 2024 года, по данным Минцифры, на нём зарегистрировались более 112 миллионов человек. Около 60 миллионов заходят на портал или в приложение хотя бы раз в месяц.
+              <a:t>[Егор]
+Если выбрать один символ цифровизации России, это, пожалуй, Госуслуги. Портал запустили 15 декабря 2009 года, а к концу 2024 года, по данным Минцифры, на нём зарегистрировались более 112 миллионов человек. Около 60 миллионов заходят на портал или в приложение хотя бы раз в месяц.
 Что это изменило в жизни людей? Раньше, чтобы оформить загранпаспорт или пособие, нужно было собрать справки и отстоять несколько очередей. Теперь многие вещи делаются из дома: запись к врачу, заявление на паспорт, оплата штрафов и налогов, получение выплат. Часть услуг стала «проактивной» — например, при рождении ребёнка некоторые выплаты и сертификат на материнский капитал оформляются без отдельного заявления.
 С 2020 года в России появились электронные трудовые книжки — бумажную больше не нужно носить с места на место. А с 2019 года в Москве, а с 2021 года и на выборах в Государственную думу в ряде регионов используется дистанционное электронное голосование. Можно спорить о его плюсах и минусах, но сам факт показателен: даже выборы частично переехали в онлайн.</a:t>
             </a:r>
@@ -1000,9 +1005,11 @@
           <a:p>
             <a:r>
               <a:rPr lang="en-US" dirty="0"/>
-              <a:t>Очень заметно цифровизация изменила школу. Бумажный дневник, который можно было «забыть» дома, уступил место электронному: оценки и домашние задания видны и ученику, и родителям в тот же день.
+              <a:t>[Егор]
+Очень заметно цифровизация изменила школу. Бумажный дневник, который можно было «забыть» дома, уступил место электронному: оценки и домашние задания видны и ученику, и родителям в тот же день.
 В Москве с 2016–2017 годов развивается «Московская электронная школа» — с цифровыми сценариями уроков, тестами и электронными учебными материалами. Похожие платформы появились и в других регионах. Для общения учителей, учеников и родителей создана платформа «Сферум».
-Но настоящую проверку школа прошла весной 2020 года, когда из-за пандемии миллионы детей за несколько дней перешли на дистанционное обучение. Было трудно: не у всех хватало компьютеров, не все учителя умели вести уроки онлайн. Зато этот опыт показал, что учиться можно и на расстоянии, а онлайн-курсы и лекции вузов стали обычным делом и для взрослых.</a:t>
+Но настоящую проверку школа прошла весной 2020 года, когда из-за пандемии миллионы детей за несколько дней перешли на дистанционное обучение. Было трудно: не у всех хватало компьютеров, не все учителя умели вести уроки онлайн. Зато этот опыт показал, что учиться можно и на расстоянии, а онлайн-курсы и лекции вузов стали обычным делом и для взрослых.
+На этом моя часть заканчивается. Передаю слово Свете — она расскажет, как цифра изменила медицину, городскую жизнь и что принесла пандемия.</a:t>
             </a:r>
             <a:endParaRPr lang="en-US" dirty="0"/>
           </a:p>
@@ -1090,7 +1097,8 @@
           <a:p>
             <a:r>
               <a:rPr lang="en-US" dirty="0"/>
-              <a:t>Посмотрим на цифровизацию глазами пациента. Первый шаг — запись к врачу. Раньше люди занимали очередь в регистратуру с утра, сегодня записаться можно через Госуслуги, региональный портал или приложение поликлиники.
+              <a:t>[Света]
+Спасибо, Егор! Посмотрим на цифровизацию глазами пациента. Первый шаг — запись к врачу. Раньше люди занимали очередь в регистратуру с утра, сегодня записаться можно через Госуслуги, региональный портал или приложение поликлиники.
 Второй шаг — консультация. С 1 января 2018 года телемедицина в России официально разрешена законом: врач может проконсультировать пациента по видеосвязи, например, обсудить результаты анализов или скорректировать лечение.
 Дальше — электронные рецепты и медицинские документы. Результаты анализов, справки, сведения о прививках можно посмотреть в личном кабинете. Особенно это ценно для тех, кто живёт далеко от крупных больниц: часть вопросов решается без долгой поездки в райцентр.</a:t>
             </a:r>
@@ -1180,9 +1188,10 @@
           <a:p>
             <a:r>
               <a:rPr lang="en-US" dirty="0"/>
-              <a:t>Цифровизация незаметно изменила и обычный день горожанина. В транспорте — транспортные карты вроде московской «Тройки», оплата проезда телефоном или банковской картой. С октября 2021 года в московском метро можно оплатить проезд с помощью биометрии — системой Face Pay, просто посмотрев в камеру на турникете.
+              <a:t>[Света]
+Цифровизация незаметно изменила и обычный день горожанина. В транспорте — транспортные карты вроде московской «Тройки», оплата проезда телефоном или банковской картой. С октября 2021 года в московском метро можно оплатить проезд с помощью биометрии — системой Face Pay, просто посмотрев в камеру на турникете.
 Такси, доставка продуктов и готовой еды, покупки в интернете, запись в парикмахерскую — всё это стало делом пары касаний. Для многих людей, особенно с маленькими детьми или ограниченной подвижностью, это реальное облегчение жизни.
-Отдельно хочу сказать о культуре. С 1 сентября 2021 года действует «Пушкинская карта»: молодые люди от 14 до 22 лет получают от государства деньги на билеты в театры, музеи, на концерты и выставки. Оформляется она в приложении, а билеты покупаются онлайн. По словам министра культуры, выпущено уже более 10 миллионов таких карт. Это хороший пример того, как цифровой инструмент приводит людей в совсем не цифровые места — в театр и музей.</a:t>
+Отдельно хочется сказать о культуре. С 1 сентября 2021 года действует «Пушкинская карта»: молодые люди от 14 до 22 лет получают от государства деньги на билеты в театры, музеи, на концерты и выставки. Оформляется она в приложении, а билеты покупаются онлайн. По словам министра культуры, выпущено уже более 10 миллионов таких карт. Это хороший пример того, как цифровой инструмент приводит людей в совсем не цифровые места — в театр и музей.</a:t>
             </a:r>
             <a:endParaRPr lang="en-US" dirty="0"/>
           </a:p>
@@ -1270,7 +1279,8 @@
           <a:p>
             <a:r>
               <a:rPr lang="en-US" dirty="0"/>
-              <a:t>Если бы нужно было назвать год, который сильнее всего ускорил цифровизацию, это 2020-й. С весны миллионы людей перешли на удалённую работу, школьники и студенты — на дистанционное обучение.
+              <a:t>[Света]
+Если бы нужно было назвать год, который сильнее всего ускорил цифровизацию, это 2020-й. С весны миллионы людей перешли на удалённую работу, школьники и студенты — на дистанционное обучение.
 В апреле 2020 года в Москве ввели цифровые пропуска для передвижения по городу — их оформляли онлайн. Резко выросли доставка, онлайн-консультации врачей, видеозвонки: многие бабушки и дедушки впервые освоили видеосвязь, чтобы увидеть внуков.
 В 2021 году появились QR-коды о вакцинации или перенесённой болезни — их показывали на входе в кафе, театры и торговые центры. Отношение к этим мерам было разным, но с точки зрения цифровизации главное другое: то, на что в обычное время ушли бы годы, произошло за месяцы.</a:t>
             </a:r>
@@ -1360,7 +1370,8 @@
           <a:p>
             <a:r>
               <a:rPr lang="en-US" dirty="0"/>
-              <a:t>Было бы нечестно говорить только о плюсах. У цифровизации есть обратная сторона, и о ней важно знать.
+              <a:t>[Света]
+Было бы нечестно говорить только о плюсах. У цифровизации есть обратная сторона, и о ней важно знать.
 Первое — цифровое неравенство. Пожилым людям и жителям отдалённых сёл бывает сложно освоить новые сервисы, а когда что-то переходит «только в онлайн», они рискуют остаться без помощи.
 Второе — мошенники. Телефонные и интернет-мошенники пользуются тем, что люди доверяют звонкам «из банка» или «из поликлиники». Третье — личные данные: утечки баз данных заставляют задуматься, кто и как хранит информацию о нас. И четвёртое — цифровая усталость: жизнь в смартфоне отнимает время на живое общение, прогулки и сон.
 Общий ответ на эти вызовы — цифровая грамотность. Технологии сами по себе не хорошие и не плохие; важно уметь пользоваться ими безопасно и осознанно.</a:t>
@@ -2371,7 +2382,7 @@
                 <a:ea typeface="Courier New" pitchFamily="34" charset="-122"/>
                 <a:cs typeface="Courier New" pitchFamily="34" charset="-120"/>
               </a:rPr>
-              <a:t>[ФИО докладчика]  ·  2026</a:t>
+              <a:t>Егор  ·  Света  ·  2026</a:t>
             </a:r>
             <a:endParaRPr lang="ru-RU" sz="1300" dirty="0"/>
           </a:p>

</xml_diff>

<commit_message>
Alternate speakers slide by slide, drop introduction line
Co-Authored-By: Claude Opus 5.5 <noreply@anthropic.com>
Claude-Session: https://claude.ai/code/session_019XwRdqvMoKnJvFiroXySfz
</commit_message>
<xml_diff>
--- a/cifrovizaciya/Цифровизация_общества_РФ.pptx
+++ b/cifrovizaciya/Цифровизация_общества_РФ.pptx
@@ -116,18 +116,18 @@
   <p:extLst>
     <p:ext uri="{521415D9-36F7-43E2-AB2F-B90AF26B5E84}">
       <p14:sectionLst xmlns:p14="http://schemas.microsoft.com/office/powerpoint/2010/main">
-        <p14:section name="Введение" id="{3b9367c3-3e10-c94f-80bb-82c06782f2ff}">
+        <p14:section name="Введение" id="{7d12d654-cbf0-6940-0152-9a88cc5f0623}">
           <p14:sldIdLst>
             <p14:sldId id="256"/>
           </p14:sldIdLst>
         </p14:section>
-        <p14:section name="История" id="{9a2b20b6-0b26-ee88-ed53-112263fd3763}">
+        <p14:section name="История" id="{160026ca-366d-9de4-a9d4-00e3f888a0c2}">
           <p14:sldIdLst>
             <p14:sldId id="257"/>
             <p14:sldId id="258"/>
           </p14:sldIdLst>
         </p14:section>
-        <p14:section name="Сферы жизни" id="{34a6ad39-b4c6-a979-fa85-a38cd7623641}">
+        <p14:section name="Сферы жизни" id="{2f02d7bc-3374-69c3-51f8-4bbb9235f0de}">
           <p14:sldIdLst>
             <p14:sldId id="259"/>
             <p14:sldId id="260"/>
@@ -135,13 +135,13 @@
             <p14:sldId id="262"/>
           </p14:sldIdLst>
         </p14:section>
-        <p14:section name="Перелом и вызовы" id="{46d08882-ffdd-65b6-c2fa-e9593adfd174}">
+        <p14:section name="Перелом и вызовы" id="{300cb639-6ef8-5324-ded5-f5d5ba695546}">
           <p14:sldIdLst>
             <p14:sldId id="263"/>
             <p14:sldId id="264"/>
           </p14:sldIdLst>
         </p14:section>
-        <p14:section name="Итоги" id="{83d88c01-f0ee-19fb-0d66-44ad287040b3}">
+        <p14:section name="Итоги" id="{f8740116-95d3-12b6-243a-41efaf53f5d7}">
           <p14:sldIdLst>
             <p14:sldId id="265"/>
           </p14:sldIdLst>
@@ -551,8 +551,8 @@
             <a:r>
               <a:rPr lang="en-US" dirty="0"/>
               <a:t>[Егор]
-Добрый день! Меня зовут Егор, а это Света. Тема нашего доклада — как цифровизация входила в жизнь общества России. Сразу оговоримся: мы не будем говорить об экономике, ВВП и рынке IT. Нас интересует другое — как цифровые технологии изменили повседневную жизнь обычного человека: как мы общаемся, учимся, лечимся, ездим по городу, ходим в театр и решаем вопросы с государством.
-Ещё тридцать лет назад интернет в России был диковинкой для учёных и энтузиастов. Сегодня у большинства из нас в кармане смартфон, через который можно записаться к врачу, проверить оценки ребёнка, оплатить проезд и купить билет в музей. Как мы к этому пришли — об этом и поговорим. Первую часть расскажу я, вторую — Света.</a:t>
+Добрый день! Тема нашего доклада — как цифровизация входила в жизнь общества России. Сразу оговоримся: мы не будем говорить об экономике, ВВП и рынке IT. Нас интересует другое — как цифровые технологии изменили повседневную жизнь обычного человека: как мы общаемся, учимся, лечимся, ездим по городу, ходим в театр и решаем вопросы с государством.
+Ещё тридцать лет назад интернет в России был диковинкой для учёных и энтузиастов. Сегодня у большинства из нас в кармане смартфон, через который можно записаться к врачу, проверить оценки ребёнка, оплатить проезд и купить билет в музей. Как мы к этому пришли — об этом и поговорим.</a:t>
             </a:r>
             <a:endParaRPr lang="en-US" dirty="0"/>
           </a:p>
@@ -731,7 +731,7 @@
           <a:p>
             <a:r>
               <a:rPr lang="en-US" dirty="0"/>
-              <a:t>[Егор]
+              <a:t>[Света]
 Отправной точкой российского интернета принято считать 7 апреля 1994 года — в этот день был зарегистрирован национальный домен .RU. У Рунета появился собственный «адрес», и эту дату до сих пор отмечают как день рождения Рунета.
 Дальше события развивались быстро. В 1996 году заработал Rambler — один из первых российских поисковиков, в 1997 году появился Яндекс. Именно поисковики сделали интернет полезным для обычного человека: в сети стало можно найти расписание, новости, рецепт или ответ на вопрос.
 Следующий перелом — 2006 год, когда появились «ВКонтакте» и «Одноклассники». Общение начало уходить в сеть: люди находили одноклассников, сослуживцев, родственников в других городах. Интернет стал не только справочником, но и местом встречи.
@@ -914,7 +914,7 @@
           <a:p>
             <a:r>
               <a:rPr lang="en-US" dirty="0"/>
-              <a:t>[Егор]
+              <a:t>[Света]
 Если выбрать один символ цифровизации России, это, пожалуй, Госуслуги. Портал запустили 15 декабря 2009 года, а к концу 2024 года, по данным Минцифры, на нём зарегистрировались более 112 миллионов человек. Около 60 миллионов заходят на портал или в приложение хотя бы раз в месяц.
 Что это изменило в жизни людей? Раньше, чтобы оформить загранпаспорт или пособие, нужно было собрать справки и отстоять несколько очередей. Теперь многие вещи делаются из дома: запись к врачу, заявление на паспорт, оплата штрафов и налогов, получение выплат. Часть услуг стала «проактивной» — например, при рождении ребёнка некоторые выплаты и сертификат на материнский капитал оформляются без отдельного заявления.
 С 2020 года в России появились электронные трудовые книжки — бумажную больше не нужно носить с места на место. А с 2019 года в Москве, а с 2021 года и на выборах в Государственную думу в ряде регионов используется дистанционное электронное голосование. Можно спорить о его плюсах и минусах, но сам факт показателен: даже выборы частично переехали в онлайн.</a:t>
@@ -1008,8 +1008,7 @@
               <a:t>[Егор]
 Очень заметно цифровизация изменила школу. Бумажный дневник, который можно было «забыть» дома, уступил место электронному: оценки и домашние задания видны и ученику, и родителям в тот же день.
 В Москве с 2016–2017 годов развивается «Московская электронная школа» — с цифровыми сценариями уроков, тестами и электронными учебными материалами. Похожие платформы появились и в других регионах. Для общения учителей, учеников и родителей создана платформа «Сферум».
-Но настоящую проверку школа прошла весной 2020 года, когда из-за пандемии миллионы детей за несколько дней перешли на дистанционное обучение. Было трудно: не у всех хватало компьютеров, не все учителя умели вести уроки онлайн. Зато этот опыт показал, что учиться можно и на расстоянии, а онлайн-курсы и лекции вузов стали обычным делом и для взрослых.
-На этом моя часть заканчивается. Передаю слово Свете — она расскажет, как цифра изменила медицину, городскую жизнь и что принесла пандемия.</a:t>
+Но настоящую проверку школа прошла весной 2020 года, когда из-за пандемии миллионы детей за несколько дней перешли на дистанционное обучение. Было трудно: не у всех хватало компьютеров, не все учителя умели вести уроки онлайн. Зато этот опыт показал, что учиться можно и на расстоянии, а онлайн-курсы и лекции вузов стали обычным делом и для взрослых.</a:t>
             </a:r>
             <a:endParaRPr lang="en-US" dirty="0"/>
           </a:p>
@@ -1098,7 +1097,7 @@
             <a:r>
               <a:rPr lang="en-US" dirty="0"/>
               <a:t>[Света]
-Спасибо, Егор! Посмотрим на цифровизацию глазами пациента. Первый шаг — запись к врачу. Раньше люди занимали очередь в регистратуру с утра, сегодня записаться можно через Госуслуги, региональный портал или приложение поликлиники.
+Посмотрим на цифровизацию глазами пациента. Первый шаг — запись к врачу. Раньше люди занимали очередь в регистратуру с утра, сегодня записаться можно через Госуслуги, региональный портал или приложение поликлиники.
 Второй шаг — консультация. С 1 января 2018 года телемедицина в России официально разрешена законом: врач может проконсультировать пациента по видеосвязи, например, обсудить результаты анализов или скорректировать лечение.
 Дальше — электронные рецепты и медицинские документы. Результаты анализов, справки, сведения о прививках можно посмотреть в личном кабинете. Особенно это ценно для тех, кто живёт далеко от крупных больниц: часть вопросов решается без долгой поездки в райцентр.</a:t>
             </a:r>
@@ -1188,7 +1187,7 @@
           <a:p>
             <a:r>
               <a:rPr lang="en-US" dirty="0"/>
-              <a:t>[Света]
+              <a:t>[Егор]
 Цифровизация незаметно изменила и обычный день горожанина. В транспорте — транспортные карты вроде московской «Тройки», оплата проезда телефоном или банковской картой. С октября 2021 года в московском метро можно оплатить проезд с помощью биометрии — системой Face Pay, просто посмотрев в камеру на турникете.
 Такси, доставка продуктов и готовой еды, покупки в интернете, запись в парикмахерскую — всё это стало делом пары касаний. Для многих людей, особенно с маленькими детьми или ограниченной подвижностью, это реальное облегчение жизни.
 Отдельно хочется сказать о культуре. С 1 сентября 2021 года действует «Пушкинская карта»: молодые люди от 14 до 22 лет получают от государства деньги на билеты в театры, музеи, на концерты и выставки. Оформляется она в приложении, а билеты покупаются онлайн. По словам министра культуры, выпущено уже более 10 миллионов таких карт. Это хороший пример того, как цифровой инструмент приводит людей в совсем не цифровые места — в театр и музей.</a:t>
@@ -1370,7 +1369,7 @@
           <a:p>
             <a:r>
               <a:rPr lang="en-US" dirty="0"/>
-              <a:t>[Света]
+              <a:t>[Егор]
 Было бы нечестно говорить только о плюсах. У цифровизации есть обратная сторона, и о ней важно знать.
 Первое — цифровое неравенство. Пожилым людям и жителям отдалённых сёл бывает сложно освоить новые сервисы, а когда что-то переходит «только в онлайн», они рискуют остаться без помощи.
 Второе — мошенники. Телефонные и интернет-мошенники пользуются тем, что люди доверяют звонкам «из банка» или «из поликлиники». Третье — личные данные: утечки баз данных заставляют задуматься, кто и как хранит информацию о нас. И четвёртое — цифровая усталость: жизнь в смартфоне отнимает время на живое общение, прогулки и сон.

</xml_diff>